<commit_message>
Rehacer la plantilla PowerPoint en 6 diapositivas editables.
Cada apartado (portada, objetivo, método, resultados, conclusiones y cierre) es una diapositiva con textos nativos, no una imagen única.

Co-authored-by: Cursor <cursoragent@cursor.com>
</commit_message>
<xml_diff>
--- a/docs/plantillas/plantilla-presentacion-jornadas-ia-2026.pptx
+++ b/docs/plantillas/plantilla-presentacion-jornadas-ia-2026.pptx
@@ -6,6 +6,11 @@
   </p:sldMasterIdLst>
   <p:sldIdLst>
     <p:sldId id="256" r:id="rId7"/>
+    <p:sldId id="257" r:id="rId8"/>
+    <p:sldId id="258" r:id="rId9"/>
+    <p:sldId id="259" r:id="rId10"/>
+    <p:sldId id="260" r:id="rId11"/>
+    <p:sldId id="261" r:id="rId12"/>
   </p:sldIdLst>
   <p:sldSz cx="12191695" cy="6858000" type="screen4x3"/>
   <p:notesSz cx="6858000" cy="9144000"/>
@@ -3140,7 +3145,7 @@
         <p:spPr>
           <a:xfrm>
             <a:off x="0" y="0"/>
-            <a:ext cx="12191695" cy="1234440"/>
+            <a:ext cx="12191695" cy="1051560"/>
           </a:xfrm>
           <a:prstGeom prst="rect">
             <a:avLst/>
@@ -3182,8 +3187,8 @@
         </p:nvSpPr>
         <p:spPr>
           <a:xfrm>
-            <a:off x="0" y="1234440"/>
-            <a:ext cx="12191695" cy="54864"/>
+            <a:off x="0" y="1051560"/>
+            <a:ext cx="12191695" cy="45720"/>
           </a:xfrm>
           <a:prstGeom prst="rect">
             <a:avLst/>
@@ -3233,8 +3238,8 @@
         </p:blipFill>
         <p:spPr>
           <a:xfrm>
-            <a:off x="320040" y="137160"/>
-            <a:ext cx="960120" cy="960120"/>
+            <a:off x="274320" y="109728"/>
+            <a:ext cx="822960" cy="822960"/>
           </a:xfrm>
           <a:prstGeom prst="rect">
             <a:avLst/>
@@ -3249,8 +3254,8 @@
         </p:nvSpPr>
         <p:spPr>
           <a:xfrm>
-            <a:off x="1463040" y="201168"/>
-            <a:ext cx="10241280" cy="960120"/>
+            <a:off x="1280160" y="164592"/>
+            <a:ext cx="9601200" cy="822960"/>
           </a:xfrm>
           <a:prstGeom prst="rect">
             <a:avLst/>
@@ -3263,9 +3268,13 @@
           </a:bodyPr>
           <a:lstStyle/>
           <a:p>
-            <a:pPr algn="l"/>
-            <a:r>
-              <a:rPr sz="1200" b="0">
+            <a:pPr algn="l">
+              <a:spcAft>
+                <a:spcPts val="800"/>
+              </a:spcAft>
+            </a:pPr>
+            <a:r>
+              <a:rPr sz="1100" b="0">
                 <a:solidFill>
                   <a:srgbClr val="FFFFFF"/>
                 </a:solidFill>
@@ -3275,9 +3284,13 @@
             </a:r>
           </a:p>
           <a:p>
-            <a:pPr algn="l"/>
-            <a:r>
-              <a:rPr sz="2200" b="1">
+            <a:pPr algn="l">
+              <a:spcAft>
+                <a:spcPts val="800"/>
+              </a:spcAft>
+            </a:pPr>
+            <a:r>
+              <a:rPr sz="1800" b="1">
                 <a:solidFill>
                   <a:srgbClr val="FFFFFF"/>
                 </a:solidFill>
@@ -3287,9 +3300,13 @@
             </a:r>
           </a:p>
           <a:p>
-            <a:pPr algn="l"/>
-            <a:r>
-              <a:rPr sz="1300" b="0">
+            <a:pPr algn="l">
+              <a:spcAft>
+                <a:spcPts val="800"/>
+              </a:spcAft>
+            </a:pPr>
+            <a:r>
+              <a:rPr sz="1200" b="0">
                 <a:solidFill>
                   <a:srgbClr val="FFFFFF"/>
                 </a:solidFill>
@@ -3302,14 +3319,57 @@
       </p:sp>
       <p:sp>
         <p:nvSpPr>
-          <p:cNvPr id="7" name="TextBox 6"/>
+          <p:cNvPr id="7" name="Rectangle 6"/>
+          <p:cNvSpPr/>
+          <p:nvPr/>
+        </p:nvSpPr>
+        <p:spPr>
+          <a:xfrm>
+            <a:off x="0" y="6492240"/>
+            <a:ext cx="12191695" cy="365760"/>
+          </a:xfrm>
+          <a:prstGeom prst="rect">
+            <a:avLst/>
+          </a:prstGeom>
+          <a:solidFill>
+            <a:srgbClr val="064A38"/>
+          </a:solidFill>
+          <a:ln>
+            <a:noFill/>
+          </a:ln>
+        </p:spPr>
+        <p:style>
+          <a:lnRef idx="1">
+            <a:schemeClr val="accent1"/>
+          </a:lnRef>
+          <a:fillRef idx="3">
+            <a:schemeClr val="accent1"/>
+          </a:fillRef>
+          <a:effectRef idx="2">
+            <a:schemeClr val="accent1"/>
+          </a:effectRef>
+          <a:fontRef idx="minor">
+            <a:schemeClr val="lt1"/>
+          </a:fontRef>
+        </p:style>
+        <p:txBody>
+          <a:bodyPr rtlCol="0" anchor="ctr"/>
+          <a:lstStyle/>
+          <a:p>
+            <a:pPr algn="ctr"/>
+          </a:p>
+        </p:txBody>
+      </p:sp>
+      <p:sp>
+        <p:nvSpPr>
+          <p:cNvPr id="8" name="TextBox 7"/>
           <p:cNvSpPr txBox="1"/>
           <p:nvPr/>
         </p:nvSpPr>
         <p:spPr>
           <a:xfrm>
-            <a:off x="640080" y="1691640"/>
-            <a:ext cx="10972800" cy="1097280"/>
+            <a:off x="365760" y="6528816"/>
+            <a:ext cx="10515600" cy="292608"/>
           </a:xfrm>
           <a:prstGeom prst="rect">
             <a:avLst/>
@@ -3322,41 +3382,33 @@
           </a:bodyPr>
           <a:lstStyle/>
           <a:p>
-            <a:pPr algn="l"/>
-            <a:r>
-              <a:rPr sz="2800" b="1">
-                <a:solidFill>
-                  <a:srgbClr val="042F23"/>
+            <a:pPr algn="ctr">
+              <a:spcAft>
+                <a:spcPts val="800"/>
+              </a:spcAft>
+            </a:pPr>
+            <a:r>
+              <a:rPr sz="1100" b="0">
+                <a:solidFill>
+                  <a:srgbClr val="FFFFFF"/>
                 </a:solidFill>
                 <a:latin typeface="Calibri"/>
               </a:rPr>
-              <a:t>Título de la ponencia</a:t>
-            </a:r>
-          </a:p>
-          <a:p>
-            <a:pPr algn="l"/>
-            <a:r>
-              <a:rPr sz="1400" b="0">
-                <a:solidFill>
-                  <a:srgbClr val="5C4F54"/>
-                </a:solidFill>
-                <a:latin typeface="Calibri"/>
-              </a:rPr>
-              <a:t>(reemplazar por el título del trabajo)</a:t>
-            </a:r>
-          </a:p>
-        </p:txBody>
-      </p:sp>
-      <p:sp>
-        <p:nvSpPr>
-          <p:cNvPr id="8" name="TextBox 7"/>
+              <a:t>Observatorio de IA · UCCuyo  ·  Diapositiva 1/6  ·  https://claudiomlarrea.github.io/observatorio-ia/#jornadas-ia</a:t>
+            </a:r>
+          </a:p>
+        </p:txBody>
+      </p:sp>
+      <p:sp>
+        <p:nvSpPr>
+          <p:cNvPr id="9" name="TextBox 8"/>
           <p:cNvSpPr txBox="1"/>
           <p:nvPr/>
         </p:nvSpPr>
         <p:spPr>
           <a:xfrm>
-            <a:off x="640080" y="2926080"/>
-            <a:ext cx="10972800" cy="1280160"/>
+            <a:off x="548640" y="1280160"/>
+            <a:ext cx="10972800" cy="502920"/>
           </a:xfrm>
           <a:prstGeom prst="rect">
             <a:avLst/>
@@ -3369,53 +3421,33 @@
           </a:bodyPr>
           <a:lstStyle/>
           <a:p>
-            <a:pPr algn="l"/>
-            <a:r>
-              <a:rPr sz="1800" b="1">
-                <a:solidFill>
-                  <a:srgbClr val="1F1418"/>
+            <a:pPr algn="l">
+              <a:spcAft>
+                <a:spcPts val="800"/>
+              </a:spcAft>
+            </a:pPr>
+            <a:r>
+              <a:rPr sz="2600" b="1">
+                <a:solidFill>
+                  <a:srgbClr val="042F23"/>
                 </a:solidFill>
                 <a:latin typeface="Calibri"/>
               </a:rPr>
-              <a:t>Autores: N. Apellido¹, N. Apellido²</a:t>
-            </a:r>
-          </a:p>
-          <a:p>
-            <a:pPr algn="l"/>
-            <a:r>
-              <a:rPr sz="1600" b="0">
-                <a:solidFill>
-                  <a:srgbClr val="5C4F54"/>
-                </a:solidFill>
-                <a:latin typeface="Calibri"/>
-              </a:rPr>
-              <a:t>Unidad académica / Facultad o Instituto</a:t>
-            </a:r>
-          </a:p>
-          <a:p>
-            <a:pPr algn="l"/>
-            <a:r>
-              <a:rPr sz="1400" b="0">
-                <a:solidFill>
-                  <a:srgbClr val="5C4F54"/>
-                </a:solidFill>
-                <a:latin typeface="Calibri"/>
-              </a:rPr>
-              <a:t>correo@uccuyo.edu.ar</a:t>
-            </a:r>
-          </a:p>
-        </p:txBody>
-      </p:sp>
-      <p:sp>
-        <p:nvSpPr>
-          <p:cNvPr id="9" name="Rounded Rectangle 8"/>
+              <a:t>1. Portada</a:t>
+            </a:r>
+          </a:p>
+        </p:txBody>
+      </p:sp>
+      <p:sp>
+        <p:nvSpPr>
+          <p:cNvPr id="10" name="Rounded Rectangle 9"/>
           <p:cNvSpPr/>
           <p:nvPr/>
         </p:nvSpPr>
         <p:spPr>
           <a:xfrm>
-            <a:off x="640080" y="4297680"/>
-            <a:ext cx="10972800" cy="1737360"/>
+            <a:off x="548640" y="1920240"/>
+            <a:ext cx="11064240" cy="4206240"/>
           </a:xfrm>
           <a:prstGeom prst="roundRect">
             <a:avLst/>
@@ -3444,6 +3476,192 @@
           </a:fontRef>
         </p:style>
         <p:txBody>
+          <a:bodyPr rtlCol="0" anchor="ctr" wrap="square"/>
+          <a:lstStyle/>
+          <a:p>
+            <a:pPr algn="l">
+              <a:spcAft>
+                <a:spcPts val="800"/>
+              </a:spcAft>
+            </a:pPr>
+            <a:r>
+              <a:rPr sz="2800" b="1">
+                <a:solidFill>
+                  <a:srgbClr val="042F23"/>
+                </a:solidFill>
+                <a:latin typeface="Calibri"/>
+              </a:rPr>
+              <a:t>Título de la ponencia</a:t>
+            </a:r>
+          </a:p>
+          <a:p>
+            <a:pPr algn="l">
+              <a:spcAft>
+                <a:spcPts val="800"/>
+              </a:spcAft>
+            </a:pPr>
+            <a:r>
+              <a:rPr sz="1400" b="0">
+                <a:solidFill>
+                  <a:srgbClr val="5C4F54"/>
+                </a:solidFill>
+                <a:latin typeface="Calibri"/>
+              </a:rPr>
+              <a:t>(hacé clic aquí y reemplazá este texto)</a:t>
+            </a:r>
+          </a:p>
+          <a:p>
+            <a:pPr algn="l">
+              <a:spcAft>
+                <a:spcPts val="800"/>
+              </a:spcAft>
+            </a:pPr>
+            <a:r>
+              <a:rPr sz="1000" b="0">
+                <a:solidFill>
+                  <a:srgbClr val="5C4F54"/>
+                </a:solidFill>
+                <a:latin typeface="Calibri"/>
+              </a:rPr>
+              <a:t/>
+            </a:r>
+          </a:p>
+          <a:p>
+            <a:pPr algn="l">
+              <a:spcAft>
+                <a:spcPts val="800"/>
+              </a:spcAft>
+            </a:pPr>
+            <a:r>
+              <a:rPr sz="1800" b="1">
+                <a:solidFill>
+                  <a:srgbClr val="1F1418"/>
+                </a:solidFill>
+                <a:latin typeface="Calibri"/>
+              </a:rPr>
+              <a:t>Autores: N. Apellido¹, N. Apellido²</a:t>
+            </a:r>
+          </a:p>
+          <a:p>
+            <a:pPr algn="l">
+              <a:spcAft>
+                <a:spcPts val="800"/>
+              </a:spcAft>
+            </a:pPr>
+            <a:r>
+              <a:rPr sz="1600" b="0">
+                <a:solidFill>
+                  <a:srgbClr val="5C4F54"/>
+                </a:solidFill>
+                <a:latin typeface="Calibri"/>
+              </a:rPr>
+              <a:t>Unidad académica / Facultad o Instituto</a:t>
+            </a:r>
+          </a:p>
+          <a:p>
+            <a:pPr algn="l">
+              <a:spcAft>
+                <a:spcPts val="800"/>
+              </a:spcAft>
+            </a:pPr>
+            <a:r>
+              <a:rPr sz="1400" b="0">
+                <a:solidFill>
+                  <a:srgbClr val="5C4F54"/>
+                </a:solidFill>
+                <a:latin typeface="Calibri"/>
+              </a:rPr>
+              <a:t>correo@uccuyo.edu.ar</a:t>
+            </a:r>
+          </a:p>
+          <a:p>
+            <a:pPr algn="l">
+              <a:spcAft>
+                <a:spcPts val="800"/>
+              </a:spcAft>
+            </a:pPr>
+            <a:r>
+              <a:rPr sz="1000" b="0">
+                <a:solidFill>
+                  <a:srgbClr val="5C4F54"/>
+                </a:solidFill>
+                <a:latin typeface="Calibri"/>
+              </a:rPr>
+              <a:t/>
+            </a:r>
+          </a:p>
+          <a:p>
+            <a:pPr algn="l">
+              <a:spcAft>
+                <a:spcPts val="800"/>
+              </a:spcAft>
+            </a:pPr>
+            <a:r>
+              <a:rPr sz="1300" b="0">
+                <a:solidFill>
+                  <a:srgbClr val="5C4F54"/>
+                </a:solidFill>
+                <a:latin typeface="Calibri"/>
+              </a:rPr>
+              <a:t>Cómo usar esta plantilla: hay 6 diapositivas editables. Hacé clic en cada texto para modificarlo. Duplicá diapositivas solo si hace falta (máximo 6 en total).</a:t>
+            </a:r>
+          </a:p>
+        </p:txBody>
+      </p:sp>
+    </p:spTree>
+  </p:cSld>
+  <p:clrMapOvr>
+    <a:masterClrMapping/>
+  </p:clrMapOvr>
+</p:sld>
+</file>
+
+<file path=ppt/slides/slide2.xml><?xml version="1.0" encoding="utf-8"?>
+<p:sld xmlns:a="http://schemas.openxmlformats.org/drawingml/2006/main" xmlns:p="http://schemas.openxmlformats.org/presentationml/2006/main" xmlns:r="http://schemas.openxmlformats.org/officeDocument/2006/relationships">
+  <p:cSld>
+    <p:spTree>
+      <p:nvGrpSpPr>
+        <p:cNvPr id="1" name=""/>
+        <p:cNvGrpSpPr/>
+        <p:nvPr/>
+      </p:nvGrpSpPr>
+      <p:grpSpPr/>
+      <p:sp>
+        <p:nvSpPr>
+          <p:cNvPr id="2" name="Rectangle 1"/>
+          <p:cNvSpPr/>
+          <p:nvPr/>
+        </p:nvSpPr>
+        <p:spPr>
+          <a:xfrm>
+            <a:off x="0" y="0"/>
+            <a:ext cx="12191695" cy="6858000"/>
+          </a:xfrm>
+          <a:prstGeom prst="rect">
+            <a:avLst/>
+          </a:prstGeom>
+          <a:solidFill>
+            <a:srgbClr val="FFFFFF"/>
+          </a:solidFill>
+          <a:ln>
+            <a:noFill/>
+          </a:ln>
+        </p:spPr>
+        <p:style>
+          <a:lnRef idx="1">
+            <a:schemeClr val="accent1"/>
+          </a:lnRef>
+          <a:fillRef idx="3">
+            <a:schemeClr val="accent1"/>
+          </a:fillRef>
+          <a:effectRef idx="2">
+            <a:schemeClr val="accent1"/>
+          </a:effectRef>
+          <a:fontRef idx="minor">
+            <a:schemeClr val="lt1"/>
+          </a:fontRef>
+        </p:style>
+        <p:txBody>
           <a:bodyPr rtlCol="0" anchor="ctr"/>
           <a:lstStyle/>
           <a:p>
@@ -3453,14 +3671,124 @@
       </p:sp>
       <p:sp>
         <p:nvSpPr>
-          <p:cNvPr id="10" name="TextBox 9"/>
+          <p:cNvPr id="3" name="Rectangle 2"/>
+          <p:cNvSpPr/>
+          <p:nvPr/>
+        </p:nvSpPr>
+        <p:spPr>
+          <a:xfrm>
+            <a:off x="0" y="0"/>
+            <a:ext cx="12191695" cy="1051560"/>
+          </a:xfrm>
+          <a:prstGeom prst="rect">
+            <a:avLst/>
+          </a:prstGeom>
+          <a:solidFill>
+            <a:srgbClr val="042F23"/>
+          </a:solidFill>
+          <a:ln>
+            <a:noFill/>
+          </a:ln>
+        </p:spPr>
+        <p:style>
+          <a:lnRef idx="1">
+            <a:schemeClr val="accent1"/>
+          </a:lnRef>
+          <a:fillRef idx="3">
+            <a:schemeClr val="accent1"/>
+          </a:fillRef>
+          <a:effectRef idx="2">
+            <a:schemeClr val="accent1"/>
+          </a:effectRef>
+          <a:fontRef idx="minor">
+            <a:schemeClr val="lt1"/>
+          </a:fontRef>
+        </p:style>
+        <p:txBody>
+          <a:bodyPr rtlCol="0" anchor="ctr"/>
+          <a:lstStyle/>
+          <a:p>
+            <a:pPr algn="ctr"/>
+          </a:p>
+        </p:txBody>
+      </p:sp>
+      <p:sp>
+        <p:nvSpPr>
+          <p:cNvPr id="4" name="Rectangle 3"/>
+          <p:cNvSpPr/>
+          <p:nvPr/>
+        </p:nvSpPr>
+        <p:spPr>
+          <a:xfrm>
+            <a:off x="0" y="1051560"/>
+            <a:ext cx="12191695" cy="45720"/>
+          </a:xfrm>
+          <a:prstGeom prst="rect">
+            <a:avLst/>
+          </a:prstGeom>
+          <a:solidFill>
+            <a:srgbClr val="C9A227"/>
+          </a:solidFill>
+          <a:ln>
+            <a:noFill/>
+          </a:ln>
+        </p:spPr>
+        <p:style>
+          <a:lnRef idx="1">
+            <a:schemeClr val="accent1"/>
+          </a:lnRef>
+          <a:fillRef idx="3">
+            <a:schemeClr val="accent1"/>
+          </a:fillRef>
+          <a:effectRef idx="2">
+            <a:schemeClr val="accent1"/>
+          </a:effectRef>
+          <a:fontRef idx="minor">
+            <a:schemeClr val="lt1"/>
+          </a:fontRef>
+        </p:style>
+        <p:txBody>
+          <a:bodyPr rtlCol="0" anchor="ctr"/>
+          <a:lstStyle/>
+          <a:p>
+            <a:pPr algn="ctr"/>
+          </a:p>
+        </p:txBody>
+      </p:sp>
+      <p:pic>
+        <p:nvPicPr>
+          <p:cNvPr id="5" name="Picture 4" descr="logo-observatorio-ia-circle.png"/>
+          <p:cNvPicPr>
+            <a:picLocks noChangeAspect="1"/>
+          </p:cNvPicPr>
+          <p:nvPr/>
+        </p:nvPicPr>
+        <p:blipFill>
+          <a:blip r:embed="rId2"/>
+          <a:stretch>
+            <a:fillRect/>
+          </a:stretch>
+        </p:blipFill>
+        <p:spPr>
+          <a:xfrm>
+            <a:off x="274320" y="109728"/>
+            <a:ext cx="822960" cy="822960"/>
+          </a:xfrm>
+          <a:prstGeom prst="rect">
+            <a:avLst/>
+          </a:prstGeom>
+        </p:spPr>
+      </p:pic>
+      <p:sp>
+        <p:nvSpPr>
+          <p:cNvPr id="6" name="TextBox 5"/>
           <p:cNvSpPr txBox="1"/>
           <p:nvPr/>
         </p:nvSpPr>
         <p:spPr>
           <a:xfrm>
-            <a:off x="868680" y="4434840"/>
-            <a:ext cx="10515600" cy="1463040"/>
+            <a:off x="1280160" y="164592"/>
+            <a:ext cx="9601200" cy="822960"/>
           </a:xfrm>
           <a:prstGeom prst="rect">
             <a:avLst/>
@@ -3473,77 +3801,65 @@
           </a:bodyPr>
           <a:lstStyle/>
           <a:p>
-            <a:pPr algn="l"/>
-            <a:r>
-              <a:rPr sz="1400" b="1">
-                <a:solidFill>
-                  <a:srgbClr val="042F23"/>
+            <a:pPr algn="l">
+              <a:spcAft>
+                <a:spcPts val="800"/>
+              </a:spcAft>
+            </a:pPr>
+            <a:r>
+              <a:rPr sz="1100" b="0">
+                <a:solidFill>
+                  <a:srgbClr val="FFFFFF"/>
                 </a:solidFill>
                 <a:latin typeface="Calibri"/>
               </a:rPr>
-              <a:t>Contenido de la diapositiva (editá estos puntos):</a:t>
-            </a:r>
-          </a:p>
-          <a:p>
-            <a:pPr algn="l"/>
-            <a:r>
-              <a:rPr sz="1400" b="0">
-                <a:solidFill>
-                  <a:srgbClr val="1F1418"/>
+              <a:t>UNIVERSIDAD CATÓLICA DE CUYO · Observatorio de IA</a:t>
+            </a:r>
+          </a:p>
+          <a:p>
+            <a:pPr algn="l">
+              <a:spcAft>
+                <a:spcPts val="800"/>
+              </a:spcAft>
+            </a:pPr>
+            <a:r>
+              <a:rPr sz="1800" b="1">
+                <a:solidFill>
+                  <a:srgbClr val="FFFFFF"/>
                 </a:solidFill>
                 <a:latin typeface="Calibri"/>
               </a:rPr>
-              <a:t>• Objetivo / contexto</a:t>
-            </a:r>
-          </a:p>
-          <a:p>
-            <a:pPr algn="l"/>
-            <a:r>
-              <a:rPr sz="1400" b="0">
-                <a:solidFill>
-                  <a:srgbClr val="1F1418"/>
+              <a:t>1° Jornadas internas de Inteligencia Artificial 2026</a:t>
+            </a:r>
+          </a:p>
+          <a:p>
+            <a:pPr algn="l">
+              <a:spcAft>
+                <a:spcPts val="800"/>
+              </a:spcAft>
+            </a:pPr>
+            <a:r>
+              <a:rPr sz="1200" b="0">
+                <a:solidFill>
+                  <a:srgbClr val="FFFFFF"/>
                 </a:solidFill>
                 <a:latin typeface="Calibri"/>
               </a:rPr>
-              <a:t>• Método o experiencia</a:t>
-            </a:r>
-          </a:p>
-          <a:p>
-            <a:pPr algn="l"/>
-            <a:r>
-              <a:rPr sz="1400" b="0">
-                <a:solidFill>
-                  <a:srgbClr val="1F1418"/>
-                </a:solidFill>
-                <a:latin typeface="Calibri"/>
-              </a:rPr>
-              <a:t>• Resultado o mensaje clave</a:t>
-            </a:r>
-          </a:p>
-          <a:p>
-            <a:pPr algn="l"/>
-            <a:r>
-              <a:rPr sz="1200" b="0">
-                <a:solidFill>
-                  <a:srgbClr val="5C4F54"/>
-                </a:solidFill>
-                <a:latin typeface="Calibri"/>
-              </a:rPr>
-              <a:t>Máximo 6 diapositivas · Exposición hasta 10 minutos</a:t>
-            </a:r>
-          </a:p>
-        </p:txBody>
-      </p:sp>
-      <p:sp>
-        <p:nvSpPr>
-          <p:cNvPr id="11" name="Rectangle 10"/>
+              <a:t>Encuentro virtual · 6 de octubre de 2026 · 15:00 h</a:t>
+            </a:r>
+          </a:p>
+        </p:txBody>
+      </p:sp>
+      <p:sp>
+        <p:nvSpPr>
+          <p:cNvPr id="7" name="Rectangle 6"/>
           <p:cNvSpPr/>
           <p:nvPr/>
         </p:nvSpPr>
         <p:spPr>
           <a:xfrm>
-            <a:off x="0" y="6473952"/>
-            <a:ext cx="12191695" cy="384048"/>
+            <a:off x="0" y="6492240"/>
+            <a:ext cx="12191695" cy="365760"/>
           </a:xfrm>
           <a:prstGeom prst="rect">
             <a:avLst/>
@@ -3579,14 +3895,14 @@
       </p:sp>
       <p:sp>
         <p:nvSpPr>
-          <p:cNvPr id="12" name="TextBox 11"/>
+          <p:cNvPr id="8" name="TextBox 7"/>
           <p:cNvSpPr txBox="1"/>
           <p:nvPr/>
         </p:nvSpPr>
         <p:spPr>
           <a:xfrm>
-            <a:off x="457200" y="6510528"/>
-            <a:ext cx="11247120" cy="320040"/>
+            <a:off x="365760" y="6528816"/>
+            <a:ext cx="10515600" cy="292608"/>
           </a:xfrm>
           <a:prstGeom prst="rect">
             <a:avLst/>
@@ -3599,7 +3915,11 @@
           </a:bodyPr>
           <a:lstStyle/>
           <a:p>
-            <a:pPr algn="ctr"/>
+            <a:pPr algn="ctr">
+              <a:spcAft>
+                <a:spcPts val="800"/>
+              </a:spcAft>
+            </a:pPr>
             <a:r>
               <a:rPr sz="1100" b="0">
                 <a:solidFill>
@@ -3607,7 +3927,2060 @@
                 </a:solidFill>
                 <a:latin typeface="Calibri"/>
               </a:rPr>
-              <a:t>Observatorio de IA · UCCuyo  ·  https://claudiomlarrea.github.io/observatorio-ia/#jornadas-ia  ·  observatorioia@uccuyo.edu.ar</a:t>
+              <a:t>Observatorio de IA · UCCuyo  ·  Diapositiva 2/6  ·  https://claudiomlarrea.github.io/observatorio-ia/#jornadas-ia</a:t>
+            </a:r>
+          </a:p>
+        </p:txBody>
+      </p:sp>
+      <p:sp>
+        <p:nvSpPr>
+          <p:cNvPr id="9" name="TextBox 8"/>
+          <p:cNvSpPr txBox="1"/>
+          <p:nvPr/>
+        </p:nvSpPr>
+        <p:spPr>
+          <a:xfrm>
+            <a:off x="548640" y="1280160"/>
+            <a:ext cx="10972800" cy="502920"/>
+          </a:xfrm>
+          <a:prstGeom prst="rect">
+            <a:avLst/>
+          </a:prstGeom>
+          <a:noFill/>
+        </p:spPr>
+        <p:txBody>
+          <a:bodyPr wrap="square">
+            <a:spAutoFit/>
+          </a:bodyPr>
+          <a:lstStyle/>
+          <a:p>
+            <a:pPr algn="l">
+              <a:spcAft>
+                <a:spcPts val="800"/>
+              </a:spcAft>
+            </a:pPr>
+            <a:r>
+              <a:rPr sz="2600" b="1">
+                <a:solidFill>
+                  <a:srgbClr val="042F23"/>
+                </a:solidFill>
+                <a:latin typeface="Calibri"/>
+              </a:rPr>
+              <a:t>2. Objetivo / contexto</a:t>
+            </a:r>
+          </a:p>
+        </p:txBody>
+      </p:sp>
+      <p:sp>
+        <p:nvSpPr>
+          <p:cNvPr id="10" name="Rounded Rectangle 9"/>
+          <p:cNvSpPr/>
+          <p:nvPr/>
+        </p:nvSpPr>
+        <p:spPr>
+          <a:xfrm>
+            <a:off x="548640" y="1920240"/>
+            <a:ext cx="11064240" cy="4206240"/>
+          </a:xfrm>
+          <a:prstGeom prst="roundRect">
+            <a:avLst/>
+          </a:prstGeom>
+          <a:solidFill>
+            <a:srgbClr val="F4F8F6"/>
+          </a:solidFill>
+          <a:ln w="15875">
+            <a:solidFill>
+              <a:srgbClr val="064A38"/>
+            </a:solidFill>
+          </a:ln>
+        </p:spPr>
+        <p:style>
+          <a:lnRef idx="1">
+            <a:schemeClr val="accent1"/>
+          </a:lnRef>
+          <a:fillRef idx="3">
+            <a:schemeClr val="accent1"/>
+          </a:fillRef>
+          <a:effectRef idx="2">
+            <a:schemeClr val="accent1"/>
+          </a:effectRef>
+          <a:fontRef idx="minor">
+            <a:schemeClr val="lt1"/>
+          </a:fontRef>
+        </p:style>
+        <p:txBody>
+          <a:bodyPr rtlCol="0" anchor="ctr" wrap="square"/>
+          <a:lstStyle/>
+          <a:p>
+            <a:pPr algn="l">
+              <a:spcAft>
+                <a:spcPts val="800"/>
+              </a:spcAft>
+            </a:pPr>
+            <a:r>
+              <a:rPr sz="1800" b="1">
+                <a:solidFill>
+                  <a:srgbClr val="042F23"/>
+                </a:solidFill>
+                <a:latin typeface="Calibri"/>
+              </a:rPr>
+              <a:t>¿Qué problema o pregunta aborda el trabajo?</a:t>
+            </a:r>
+          </a:p>
+          <a:p>
+            <a:pPr algn="l">
+              <a:spcAft>
+                <a:spcPts val="800"/>
+              </a:spcAft>
+            </a:pPr>
+            <a:r>
+              <a:rPr sz="1600" b="0">
+                <a:solidFill>
+                  <a:srgbClr val="1F1418"/>
+                </a:solidFill>
+                <a:latin typeface="Calibri"/>
+              </a:rPr>
+              <a:t>• Escribí aquí el objetivo general</a:t>
+            </a:r>
+          </a:p>
+          <a:p>
+            <a:pPr algn="l">
+              <a:spcAft>
+                <a:spcPts val="800"/>
+              </a:spcAft>
+            </a:pPr>
+            <a:r>
+              <a:rPr sz="1600" b="0">
+                <a:solidFill>
+                  <a:srgbClr val="1F1418"/>
+                </a:solidFill>
+                <a:latin typeface="Calibri"/>
+              </a:rPr>
+              <a:t>• Contexto institucional o del área</a:t>
+            </a:r>
+          </a:p>
+          <a:p>
+            <a:pPr algn="l">
+              <a:spcAft>
+                <a:spcPts val="800"/>
+              </a:spcAft>
+            </a:pPr>
+            <a:r>
+              <a:rPr sz="1600" b="0">
+                <a:solidFill>
+                  <a:srgbClr val="1F1418"/>
+                </a:solidFill>
+                <a:latin typeface="Calibri"/>
+              </a:rPr>
+              <a:t>• Por qué importa para la UCCuyo / la región</a:t>
+            </a:r>
+          </a:p>
+        </p:txBody>
+      </p:sp>
+    </p:spTree>
+  </p:cSld>
+  <p:clrMapOvr>
+    <a:masterClrMapping/>
+  </p:clrMapOvr>
+</p:sld>
+</file>
+
+<file path=ppt/slides/slide3.xml><?xml version="1.0" encoding="utf-8"?>
+<p:sld xmlns:a="http://schemas.openxmlformats.org/drawingml/2006/main" xmlns:p="http://schemas.openxmlformats.org/presentationml/2006/main" xmlns:r="http://schemas.openxmlformats.org/officeDocument/2006/relationships">
+  <p:cSld>
+    <p:spTree>
+      <p:nvGrpSpPr>
+        <p:cNvPr id="1" name=""/>
+        <p:cNvGrpSpPr/>
+        <p:nvPr/>
+      </p:nvGrpSpPr>
+      <p:grpSpPr/>
+      <p:sp>
+        <p:nvSpPr>
+          <p:cNvPr id="2" name="Rectangle 1"/>
+          <p:cNvSpPr/>
+          <p:nvPr/>
+        </p:nvSpPr>
+        <p:spPr>
+          <a:xfrm>
+            <a:off x="0" y="0"/>
+            <a:ext cx="12191695" cy="6858000"/>
+          </a:xfrm>
+          <a:prstGeom prst="rect">
+            <a:avLst/>
+          </a:prstGeom>
+          <a:solidFill>
+            <a:srgbClr val="FFFFFF"/>
+          </a:solidFill>
+          <a:ln>
+            <a:noFill/>
+          </a:ln>
+        </p:spPr>
+        <p:style>
+          <a:lnRef idx="1">
+            <a:schemeClr val="accent1"/>
+          </a:lnRef>
+          <a:fillRef idx="3">
+            <a:schemeClr val="accent1"/>
+          </a:fillRef>
+          <a:effectRef idx="2">
+            <a:schemeClr val="accent1"/>
+          </a:effectRef>
+          <a:fontRef idx="minor">
+            <a:schemeClr val="lt1"/>
+          </a:fontRef>
+        </p:style>
+        <p:txBody>
+          <a:bodyPr rtlCol="0" anchor="ctr"/>
+          <a:lstStyle/>
+          <a:p>
+            <a:pPr algn="ctr"/>
+          </a:p>
+        </p:txBody>
+      </p:sp>
+      <p:sp>
+        <p:nvSpPr>
+          <p:cNvPr id="3" name="Rectangle 2"/>
+          <p:cNvSpPr/>
+          <p:nvPr/>
+        </p:nvSpPr>
+        <p:spPr>
+          <a:xfrm>
+            <a:off x="0" y="0"/>
+            <a:ext cx="12191695" cy="1051560"/>
+          </a:xfrm>
+          <a:prstGeom prst="rect">
+            <a:avLst/>
+          </a:prstGeom>
+          <a:solidFill>
+            <a:srgbClr val="042F23"/>
+          </a:solidFill>
+          <a:ln>
+            <a:noFill/>
+          </a:ln>
+        </p:spPr>
+        <p:style>
+          <a:lnRef idx="1">
+            <a:schemeClr val="accent1"/>
+          </a:lnRef>
+          <a:fillRef idx="3">
+            <a:schemeClr val="accent1"/>
+          </a:fillRef>
+          <a:effectRef idx="2">
+            <a:schemeClr val="accent1"/>
+          </a:effectRef>
+          <a:fontRef idx="minor">
+            <a:schemeClr val="lt1"/>
+          </a:fontRef>
+        </p:style>
+        <p:txBody>
+          <a:bodyPr rtlCol="0" anchor="ctr"/>
+          <a:lstStyle/>
+          <a:p>
+            <a:pPr algn="ctr"/>
+          </a:p>
+        </p:txBody>
+      </p:sp>
+      <p:sp>
+        <p:nvSpPr>
+          <p:cNvPr id="4" name="Rectangle 3"/>
+          <p:cNvSpPr/>
+          <p:nvPr/>
+        </p:nvSpPr>
+        <p:spPr>
+          <a:xfrm>
+            <a:off x="0" y="1051560"/>
+            <a:ext cx="12191695" cy="45720"/>
+          </a:xfrm>
+          <a:prstGeom prst="rect">
+            <a:avLst/>
+          </a:prstGeom>
+          <a:solidFill>
+            <a:srgbClr val="C9A227"/>
+          </a:solidFill>
+          <a:ln>
+            <a:noFill/>
+          </a:ln>
+        </p:spPr>
+        <p:style>
+          <a:lnRef idx="1">
+            <a:schemeClr val="accent1"/>
+          </a:lnRef>
+          <a:fillRef idx="3">
+            <a:schemeClr val="accent1"/>
+          </a:fillRef>
+          <a:effectRef idx="2">
+            <a:schemeClr val="accent1"/>
+          </a:effectRef>
+          <a:fontRef idx="minor">
+            <a:schemeClr val="lt1"/>
+          </a:fontRef>
+        </p:style>
+        <p:txBody>
+          <a:bodyPr rtlCol="0" anchor="ctr"/>
+          <a:lstStyle/>
+          <a:p>
+            <a:pPr algn="ctr"/>
+          </a:p>
+        </p:txBody>
+      </p:sp>
+      <p:pic>
+        <p:nvPicPr>
+          <p:cNvPr id="5" name="Picture 4" descr="logo-observatorio-ia-circle.png"/>
+          <p:cNvPicPr>
+            <a:picLocks noChangeAspect="1"/>
+          </p:cNvPicPr>
+          <p:nvPr/>
+        </p:nvPicPr>
+        <p:blipFill>
+          <a:blip r:embed="rId2"/>
+          <a:stretch>
+            <a:fillRect/>
+          </a:stretch>
+        </p:blipFill>
+        <p:spPr>
+          <a:xfrm>
+            <a:off x="274320" y="109728"/>
+            <a:ext cx="822960" cy="822960"/>
+          </a:xfrm>
+          <a:prstGeom prst="rect">
+            <a:avLst/>
+          </a:prstGeom>
+        </p:spPr>
+      </p:pic>
+      <p:sp>
+        <p:nvSpPr>
+          <p:cNvPr id="6" name="TextBox 5"/>
+          <p:cNvSpPr txBox="1"/>
+          <p:nvPr/>
+        </p:nvSpPr>
+        <p:spPr>
+          <a:xfrm>
+            <a:off x="1280160" y="164592"/>
+            <a:ext cx="9601200" cy="822960"/>
+          </a:xfrm>
+          <a:prstGeom prst="rect">
+            <a:avLst/>
+          </a:prstGeom>
+          <a:noFill/>
+        </p:spPr>
+        <p:txBody>
+          <a:bodyPr wrap="square">
+            <a:spAutoFit/>
+          </a:bodyPr>
+          <a:lstStyle/>
+          <a:p>
+            <a:pPr algn="l">
+              <a:spcAft>
+                <a:spcPts val="800"/>
+              </a:spcAft>
+            </a:pPr>
+            <a:r>
+              <a:rPr sz="1100" b="0">
+                <a:solidFill>
+                  <a:srgbClr val="FFFFFF"/>
+                </a:solidFill>
+                <a:latin typeface="Calibri"/>
+              </a:rPr>
+              <a:t>UNIVERSIDAD CATÓLICA DE CUYO · Observatorio de IA</a:t>
+            </a:r>
+          </a:p>
+          <a:p>
+            <a:pPr algn="l">
+              <a:spcAft>
+                <a:spcPts val="800"/>
+              </a:spcAft>
+            </a:pPr>
+            <a:r>
+              <a:rPr sz="1800" b="1">
+                <a:solidFill>
+                  <a:srgbClr val="FFFFFF"/>
+                </a:solidFill>
+                <a:latin typeface="Calibri"/>
+              </a:rPr>
+              <a:t>1° Jornadas internas de Inteligencia Artificial 2026</a:t>
+            </a:r>
+          </a:p>
+          <a:p>
+            <a:pPr algn="l">
+              <a:spcAft>
+                <a:spcPts val="800"/>
+              </a:spcAft>
+            </a:pPr>
+            <a:r>
+              <a:rPr sz="1200" b="0">
+                <a:solidFill>
+                  <a:srgbClr val="FFFFFF"/>
+                </a:solidFill>
+                <a:latin typeface="Calibri"/>
+              </a:rPr>
+              <a:t>Encuentro virtual · 6 de octubre de 2026 · 15:00 h</a:t>
+            </a:r>
+          </a:p>
+        </p:txBody>
+      </p:sp>
+      <p:sp>
+        <p:nvSpPr>
+          <p:cNvPr id="7" name="Rectangle 6"/>
+          <p:cNvSpPr/>
+          <p:nvPr/>
+        </p:nvSpPr>
+        <p:spPr>
+          <a:xfrm>
+            <a:off x="0" y="6492240"/>
+            <a:ext cx="12191695" cy="365760"/>
+          </a:xfrm>
+          <a:prstGeom prst="rect">
+            <a:avLst/>
+          </a:prstGeom>
+          <a:solidFill>
+            <a:srgbClr val="064A38"/>
+          </a:solidFill>
+          <a:ln>
+            <a:noFill/>
+          </a:ln>
+        </p:spPr>
+        <p:style>
+          <a:lnRef idx="1">
+            <a:schemeClr val="accent1"/>
+          </a:lnRef>
+          <a:fillRef idx="3">
+            <a:schemeClr val="accent1"/>
+          </a:fillRef>
+          <a:effectRef idx="2">
+            <a:schemeClr val="accent1"/>
+          </a:effectRef>
+          <a:fontRef idx="minor">
+            <a:schemeClr val="lt1"/>
+          </a:fontRef>
+        </p:style>
+        <p:txBody>
+          <a:bodyPr rtlCol="0" anchor="ctr"/>
+          <a:lstStyle/>
+          <a:p>
+            <a:pPr algn="ctr"/>
+          </a:p>
+        </p:txBody>
+      </p:sp>
+      <p:sp>
+        <p:nvSpPr>
+          <p:cNvPr id="8" name="TextBox 7"/>
+          <p:cNvSpPr txBox="1"/>
+          <p:nvPr/>
+        </p:nvSpPr>
+        <p:spPr>
+          <a:xfrm>
+            <a:off x="365760" y="6528816"/>
+            <a:ext cx="10515600" cy="292608"/>
+          </a:xfrm>
+          <a:prstGeom prst="rect">
+            <a:avLst/>
+          </a:prstGeom>
+          <a:noFill/>
+        </p:spPr>
+        <p:txBody>
+          <a:bodyPr wrap="square">
+            <a:spAutoFit/>
+          </a:bodyPr>
+          <a:lstStyle/>
+          <a:p>
+            <a:pPr algn="ctr">
+              <a:spcAft>
+                <a:spcPts val="800"/>
+              </a:spcAft>
+            </a:pPr>
+            <a:r>
+              <a:rPr sz="1100" b="0">
+                <a:solidFill>
+                  <a:srgbClr val="FFFFFF"/>
+                </a:solidFill>
+                <a:latin typeface="Calibri"/>
+              </a:rPr>
+              <a:t>Observatorio de IA · UCCuyo  ·  Diapositiva 3/6  ·  https://claudiomlarrea.github.io/observatorio-ia/#jornadas-ia</a:t>
+            </a:r>
+          </a:p>
+        </p:txBody>
+      </p:sp>
+      <p:sp>
+        <p:nvSpPr>
+          <p:cNvPr id="9" name="TextBox 8"/>
+          <p:cNvSpPr txBox="1"/>
+          <p:nvPr/>
+        </p:nvSpPr>
+        <p:spPr>
+          <a:xfrm>
+            <a:off x="548640" y="1280160"/>
+            <a:ext cx="10972800" cy="502920"/>
+          </a:xfrm>
+          <a:prstGeom prst="rect">
+            <a:avLst/>
+          </a:prstGeom>
+          <a:noFill/>
+        </p:spPr>
+        <p:txBody>
+          <a:bodyPr wrap="square">
+            <a:spAutoFit/>
+          </a:bodyPr>
+          <a:lstStyle/>
+          <a:p>
+            <a:pPr algn="l">
+              <a:spcAft>
+                <a:spcPts val="800"/>
+              </a:spcAft>
+            </a:pPr>
+            <a:r>
+              <a:rPr sz="2600" b="1">
+                <a:solidFill>
+                  <a:srgbClr val="042F23"/>
+                </a:solidFill>
+                <a:latin typeface="Calibri"/>
+              </a:rPr>
+              <a:t>3. Método o experiencia</a:t>
+            </a:r>
+          </a:p>
+        </p:txBody>
+      </p:sp>
+      <p:sp>
+        <p:nvSpPr>
+          <p:cNvPr id="10" name="Rounded Rectangle 9"/>
+          <p:cNvSpPr/>
+          <p:nvPr/>
+        </p:nvSpPr>
+        <p:spPr>
+          <a:xfrm>
+            <a:off x="548640" y="1920240"/>
+            <a:ext cx="11064240" cy="4206240"/>
+          </a:xfrm>
+          <a:prstGeom prst="roundRect">
+            <a:avLst/>
+          </a:prstGeom>
+          <a:solidFill>
+            <a:srgbClr val="F4F8F6"/>
+          </a:solidFill>
+          <a:ln w="15875">
+            <a:solidFill>
+              <a:srgbClr val="064A38"/>
+            </a:solidFill>
+          </a:ln>
+        </p:spPr>
+        <p:style>
+          <a:lnRef idx="1">
+            <a:schemeClr val="accent1"/>
+          </a:lnRef>
+          <a:fillRef idx="3">
+            <a:schemeClr val="accent1"/>
+          </a:fillRef>
+          <a:effectRef idx="2">
+            <a:schemeClr val="accent1"/>
+          </a:effectRef>
+          <a:fontRef idx="minor">
+            <a:schemeClr val="lt1"/>
+          </a:fontRef>
+        </p:style>
+        <p:txBody>
+          <a:bodyPr rtlCol="0" anchor="ctr" wrap="square"/>
+          <a:lstStyle/>
+          <a:p>
+            <a:pPr algn="l">
+              <a:spcAft>
+                <a:spcPts val="800"/>
+              </a:spcAft>
+            </a:pPr>
+            <a:r>
+              <a:rPr sz="1800" b="1">
+                <a:solidFill>
+                  <a:srgbClr val="042F23"/>
+                </a:solidFill>
+                <a:latin typeface="Calibri"/>
+              </a:rPr>
+              <a:t>¿Cómo se hizo?</a:t>
+            </a:r>
+          </a:p>
+          <a:p>
+            <a:pPr algn="l">
+              <a:spcAft>
+                <a:spcPts val="800"/>
+              </a:spcAft>
+            </a:pPr>
+            <a:r>
+              <a:rPr sz="1600" b="0">
+                <a:solidFill>
+                  <a:srgbClr val="1F1418"/>
+                </a:solidFill>
+                <a:latin typeface="Calibri"/>
+              </a:rPr>
+              <a:t>• Enfoque o diseño (docencia, investigación, gestión…)</a:t>
+            </a:r>
+          </a:p>
+          <a:p>
+            <a:pPr algn="l">
+              <a:spcAft>
+                <a:spcPts val="800"/>
+              </a:spcAft>
+            </a:pPr>
+            <a:r>
+              <a:rPr sz="1600" b="0">
+                <a:solidFill>
+                  <a:srgbClr val="1F1418"/>
+                </a:solidFill>
+                <a:latin typeface="Calibri"/>
+              </a:rPr>
+              <a:t>• Herramientas / datos / participantes</a:t>
+            </a:r>
+          </a:p>
+          <a:p>
+            <a:pPr algn="l">
+              <a:spcAft>
+                <a:spcPts val="800"/>
+              </a:spcAft>
+            </a:pPr>
+            <a:r>
+              <a:rPr sz="1600" b="0">
+                <a:solidFill>
+                  <a:srgbClr val="1F1418"/>
+                </a:solidFill>
+                <a:latin typeface="Calibri"/>
+              </a:rPr>
+              <a:t>• Pasos principales de la experiencia</a:t>
+            </a:r>
+          </a:p>
+        </p:txBody>
+      </p:sp>
+    </p:spTree>
+  </p:cSld>
+  <p:clrMapOvr>
+    <a:masterClrMapping/>
+  </p:clrMapOvr>
+</p:sld>
+</file>
+
+<file path=ppt/slides/slide4.xml><?xml version="1.0" encoding="utf-8"?>
+<p:sld xmlns:a="http://schemas.openxmlformats.org/drawingml/2006/main" xmlns:p="http://schemas.openxmlformats.org/presentationml/2006/main" xmlns:r="http://schemas.openxmlformats.org/officeDocument/2006/relationships">
+  <p:cSld>
+    <p:spTree>
+      <p:nvGrpSpPr>
+        <p:cNvPr id="1" name=""/>
+        <p:cNvGrpSpPr/>
+        <p:nvPr/>
+      </p:nvGrpSpPr>
+      <p:grpSpPr/>
+      <p:sp>
+        <p:nvSpPr>
+          <p:cNvPr id="2" name="Rectangle 1"/>
+          <p:cNvSpPr/>
+          <p:nvPr/>
+        </p:nvSpPr>
+        <p:spPr>
+          <a:xfrm>
+            <a:off x="0" y="0"/>
+            <a:ext cx="12191695" cy="6858000"/>
+          </a:xfrm>
+          <a:prstGeom prst="rect">
+            <a:avLst/>
+          </a:prstGeom>
+          <a:solidFill>
+            <a:srgbClr val="FFFFFF"/>
+          </a:solidFill>
+          <a:ln>
+            <a:noFill/>
+          </a:ln>
+        </p:spPr>
+        <p:style>
+          <a:lnRef idx="1">
+            <a:schemeClr val="accent1"/>
+          </a:lnRef>
+          <a:fillRef idx="3">
+            <a:schemeClr val="accent1"/>
+          </a:fillRef>
+          <a:effectRef idx="2">
+            <a:schemeClr val="accent1"/>
+          </a:effectRef>
+          <a:fontRef idx="minor">
+            <a:schemeClr val="lt1"/>
+          </a:fontRef>
+        </p:style>
+        <p:txBody>
+          <a:bodyPr rtlCol="0" anchor="ctr"/>
+          <a:lstStyle/>
+          <a:p>
+            <a:pPr algn="ctr"/>
+          </a:p>
+        </p:txBody>
+      </p:sp>
+      <p:sp>
+        <p:nvSpPr>
+          <p:cNvPr id="3" name="Rectangle 2"/>
+          <p:cNvSpPr/>
+          <p:nvPr/>
+        </p:nvSpPr>
+        <p:spPr>
+          <a:xfrm>
+            <a:off x="0" y="0"/>
+            <a:ext cx="12191695" cy="1051560"/>
+          </a:xfrm>
+          <a:prstGeom prst="rect">
+            <a:avLst/>
+          </a:prstGeom>
+          <a:solidFill>
+            <a:srgbClr val="042F23"/>
+          </a:solidFill>
+          <a:ln>
+            <a:noFill/>
+          </a:ln>
+        </p:spPr>
+        <p:style>
+          <a:lnRef idx="1">
+            <a:schemeClr val="accent1"/>
+          </a:lnRef>
+          <a:fillRef idx="3">
+            <a:schemeClr val="accent1"/>
+          </a:fillRef>
+          <a:effectRef idx="2">
+            <a:schemeClr val="accent1"/>
+          </a:effectRef>
+          <a:fontRef idx="minor">
+            <a:schemeClr val="lt1"/>
+          </a:fontRef>
+        </p:style>
+        <p:txBody>
+          <a:bodyPr rtlCol="0" anchor="ctr"/>
+          <a:lstStyle/>
+          <a:p>
+            <a:pPr algn="ctr"/>
+          </a:p>
+        </p:txBody>
+      </p:sp>
+      <p:sp>
+        <p:nvSpPr>
+          <p:cNvPr id="4" name="Rectangle 3"/>
+          <p:cNvSpPr/>
+          <p:nvPr/>
+        </p:nvSpPr>
+        <p:spPr>
+          <a:xfrm>
+            <a:off x="0" y="1051560"/>
+            <a:ext cx="12191695" cy="45720"/>
+          </a:xfrm>
+          <a:prstGeom prst="rect">
+            <a:avLst/>
+          </a:prstGeom>
+          <a:solidFill>
+            <a:srgbClr val="C9A227"/>
+          </a:solidFill>
+          <a:ln>
+            <a:noFill/>
+          </a:ln>
+        </p:spPr>
+        <p:style>
+          <a:lnRef idx="1">
+            <a:schemeClr val="accent1"/>
+          </a:lnRef>
+          <a:fillRef idx="3">
+            <a:schemeClr val="accent1"/>
+          </a:fillRef>
+          <a:effectRef idx="2">
+            <a:schemeClr val="accent1"/>
+          </a:effectRef>
+          <a:fontRef idx="minor">
+            <a:schemeClr val="lt1"/>
+          </a:fontRef>
+        </p:style>
+        <p:txBody>
+          <a:bodyPr rtlCol="0" anchor="ctr"/>
+          <a:lstStyle/>
+          <a:p>
+            <a:pPr algn="ctr"/>
+          </a:p>
+        </p:txBody>
+      </p:sp>
+      <p:pic>
+        <p:nvPicPr>
+          <p:cNvPr id="5" name="Picture 4" descr="logo-observatorio-ia-circle.png"/>
+          <p:cNvPicPr>
+            <a:picLocks noChangeAspect="1"/>
+          </p:cNvPicPr>
+          <p:nvPr/>
+        </p:nvPicPr>
+        <p:blipFill>
+          <a:blip r:embed="rId2"/>
+          <a:stretch>
+            <a:fillRect/>
+          </a:stretch>
+        </p:blipFill>
+        <p:spPr>
+          <a:xfrm>
+            <a:off x="274320" y="109728"/>
+            <a:ext cx="822960" cy="822960"/>
+          </a:xfrm>
+          <a:prstGeom prst="rect">
+            <a:avLst/>
+          </a:prstGeom>
+        </p:spPr>
+      </p:pic>
+      <p:sp>
+        <p:nvSpPr>
+          <p:cNvPr id="6" name="TextBox 5"/>
+          <p:cNvSpPr txBox="1"/>
+          <p:nvPr/>
+        </p:nvSpPr>
+        <p:spPr>
+          <a:xfrm>
+            <a:off x="1280160" y="164592"/>
+            <a:ext cx="9601200" cy="822960"/>
+          </a:xfrm>
+          <a:prstGeom prst="rect">
+            <a:avLst/>
+          </a:prstGeom>
+          <a:noFill/>
+        </p:spPr>
+        <p:txBody>
+          <a:bodyPr wrap="square">
+            <a:spAutoFit/>
+          </a:bodyPr>
+          <a:lstStyle/>
+          <a:p>
+            <a:pPr algn="l">
+              <a:spcAft>
+                <a:spcPts val="800"/>
+              </a:spcAft>
+            </a:pPr>
+            <a:r>
+              <a:rPr sz="1100" b="0">
+                <a:solidFill>
+                  <a:srgbClr val="FFFFFF"/>
+                </a:solidFill>
+                <a:latin typeface="Calibri"/>
+              </a:rPr>
+              <a:t>UNIVERSIDAD CATÓLICA DE CUYO · Observatorio de IA</a:t>
+            </a:r>
+          </a:p>
+          <a:p>
+            <a:pPr algn="l">
+              <a:spcAft>
+                <a:spcPts val="800"/>
+              </a:spcAft>
+            </a:pPr>
+            <a:r>
+              <a:rPr sz="1800" b="1">
+                <a:solidFill>
+                  <a:srgbClr val="FFFFFF"/>
+                </a:solidFill>
+                <a:latin typeface="Calibri"/>
+              </a:rPr>
+              <a:t>1° Jornadas internas de Inteligencia Artificial 2026</a:t>
+            </a:r>
+          </a:p>
+          <a:p>
+            <a:pPr algn="l">
+              <a:spcAft>
+                <a:spcPts val="800"/>
+              </a:spcAft>
+            </a:pPr>
+            <a:r>
+              <a:rPr sz="1200" b="0">
+                <a:solidFill>
+                  <a:srgbClr val="FFFFFF"/>
+                </a:solidFill>
+                <a:latin typeface="Calibri"/>
+              </a:rPr>
+              <a:t>Encuentro virtual · 6 de octubre de 2026 · 15:00 h</a:t>
+            </a:r>
+          </a:p>
+        </p:txBody>
+      </p:sp>
+      <p:sp>
+        <p:nvSpPr>
+          <p:cNvPr id="7" name="Rectangle 6"/>
+          <p:cNvSpPr/>
+          <p:nvPr/>
+        </p:nvSpPr>
+        <p:spPr>
+          <a:xfrm>
+            <a:off x="0" y="6492240"/>
+            <a:ext cx="12191695" cy="365760"/>
+          </a:xfrm>
+          <a:prstGeom prst="rect">
+            <a:avLst/>
+          </a:prstGeom>
+          <a:solidFill>
+            <a:srgbClr val="064A38"/>
+          </a:solidFill>
+          <a:ln>
+            <a:noFill/>
+          </a:ln>
+        </p:spPr>
+        <p:style>
+          <a:lnRef idx="1">
+            <a:schemeClr val="accent1"/>
+          </a:lnRef>
+          <a:fillRef idx="3">
+            <a:schemeClr val="accent1"/>
+          </a:fillRef>
+          <a:effectRef idx="2">
+            <a:schemeClr val="accent1"/>
+          </a:effectRef>
+          <a:fontRef idx="minor">
+            <a:schemeClr val="lt1"/>
+          </a:fontRef>
+        </p:style>
+        <p:txBody>
+          <a:bodyPr rtlCol="0" anchor="ctr"/>
+          <a:lstStyle/>
+          <a:p>
+            <a:pPr algn="ctr"/>
+          </a:p>
+        </p:txBody>
+      </p:sp>
+      <p:sp>
+        <p:nvSpPr>
+          <p:cNvPr id="8" name="TextBox 7"/>
+          <p:cNvSpPr txBox="1"/>
+          <p:nvPr/>
+        </p:nvSpPr>
+        <p:spPr>
+          <a:xfrm>
+            <a:off x="365760" y="6528816"/>
+            <a:ext cx="10515600" cy="292608"/>
+          </a:xfrm>
+          <a:prstGeom prst="rect">
+            <a:avLst/>
+          </a:prstGeom>
+          <a:noFill/>
+        </p:spPr>
+        <p:txBody>
+          <a:bodyPr wrap="square">
+            <a:spAutoFit/>
+          </a:bodyPr>
+          <a:lstStyle/>
+          <a:p>
+            <a:pPr algn="ctr">
+              <a:spcAft>
+                <a:spcPts val="800"/>
+              </a:spcAft>
+            </a:pPr>
+            <a:r>
+              <a:rPr sz="1100" b="0">
+                <a:solidFill>
+                  <a:srgbClr val="FFFFFF"/>
+                </a:solidFill>
+                <a:latin typeface="Calibri"/>
+              </a:rPr>
+              <a:t>Observatorio de IA · UCCuyo  ·  Diapositiva 4/6  ·  https://claudiomlarrea.github.io/observatorio-ia/#jornadas-ia</a:t>
+            </a:r>
+          </a:p>
+        </p:txBody>
+      </p:sp>
+      <p:sp>
+        <p:nvSpPr>
+          <p:cNvPr id="9" name="TextBox 8"/>
+          <p:cNvSpPr txBox="1"/>
+          <p:nvPr/>
+        </p:nvSpPr>
+        <p:spPr>
+          <a:xfrm>
+            <a:off x="548640" y="1280160"/>
+            <a:ext cx="10972800" cy="502920"/>
+          </a:xfrm>
+          <a:prstGeom prst="rect">
+            <a:avLst/>
+          </a:prstGeom>
+          <a:noFill/>
+        </p:spPr>
+        <p:txBody>
+          <a:bodyPr wrap="square">
+            <a:spAutoFit/>
+          </a:bodyPr>
+          <a:lstStyle/>
+          <a:p>
+            <a:pPr algn="l">
+              <a:spcAft>
+                <a:spcPts val="800"/>
+              </a:spcAft>
+            </a:pPr>
+            <a:r>
+              <a:rPr sz="2600" b="1">
+                <a:solidFill>
+                  <a:srgbClr val="042F23"/>
+                </a:solidFill>
+                <a:latin typeface="Calibri"/>
+              </a:rPr>
+              <a:t>4. Resultados / hallazgos</a:t>
+            </a:r>
+          </a:p>
+        </p:txBody>
+      </p:sp>
+      <p:sp>
+        <p:nvSpPr>
+          <p:cNvPr id="10" name="Rounded Rectangle 9"/>
+          <p:cNvSpPr/>
+          <p:nvPr/>
+        </p:nvSpPr>
+        <p:spPr>
+          <a:xfrm>
+            <a:off x="548640" y="1920240"/>
+            <a:ext cx="11064240" cy="4206240"/>
+          </a:xfrm>
+          <a:prstGeom prst="roundRect">
+            <a:avLst/>
+          </a:prstGeom>
+          <a:solidFill>
+            <a:srgbClr val="F4F8F6"/>
+          </a:solidFill>
+          <a:ln w="15875">
+            <a:solidFill>
+              <a:srgbClr val="064A38"/>
+            </a:solidFill>
+          </a:ln>
+        </p:spPr>
+        <p:style>
+          <a:lnRef idx="1">
+            <a:schemeClr val="accent1"/>
+          </a:lnRef>
+          <a:fillRef idx="3">
+            <a:schemeClr val="accent1"/>
+          </a:fillRef>
+          <a:effectRef idx="2">
+            <a:schemeClr val="accent1"/>
+          </a:effectRef>
+          <a:fontRef idx="minor">
+            <a:schemeClr val="lt1"/>
+          </a:fontRef>
+        </p:style>
+        <p:txBody>
+          <a:bodyPr rtlCol="0" anchor="ctr" wrap="square"/>
+          <a:lstStyle/>
+          <a:p>
+            <a:pPr algn="l">
+              <a:spcAft>
+                <a:spcPts val="800"/>
+              </a:spcAft>
+            </a:pPr>
+            <a:r>
+              <a:rPr sz="1800" b="1">
+                <a:solidFill>
+                  <a:srgbClr val="042F23"/>
+                </a:solidFill>
+                <a:latin typeface="Calibri"/>
+              </a:rPr>
+              <a:t>¿Qué se obtuvo?</a:t>
+            </a:r>
+          </a:p>
+          <a:p>
+            <a:pPr algn="l">
+              <a:spcAft>
+                <a:spcPts val="800"/>
+              </a:spcAft>
+            </a:pPr>
+            <a:r>
+              <a:rPr sz="1600" b="0">
+                <a:solidFill>
+                  <a:srgbClr val="1F1418"/>
+                </a:solidFill>
+                <a:latin typeface="Calibri"/>
+              </a:rPr>
+              <a:t>• Hallazgo principal 1</a:t>
+            </a:r>
+          </a:p>
+          <a:p>
+            <a:pPr algn="l">
+              <a:spcAft>
+                <a:spcPts val="800"/>
+              </a:spcAft>
+            </a:pPr>
+            <a:r>
+              <a:rPr sz="1600" b="0">
+                <a:solidFill>
+                  <a:srgbClr val="1F1418"/>
+                </a:solidFill>
+                <a:latin typeface="Calibri"/>
+              </a:rPr>
+              <a:t>• Hallazgo principal 2</a:t>
+            </a:r>
+          </a:p>
+          <a:p>
+            <a:pPr algn="l">
+              <a:spcAft>
+                <a:spcPts val="800"/>
+              </a:spcAft>
+            </a:pPr>
+            <a:r>
+              <a:rPr sz="1600" b="0">
+                <a:solidFill>
+                  <a:srgbClr val="1F1418"/>
+                </a:solidFill>
+                <a:latin typeface="Calibri"/>
+              </a:rPr>
+              <a:t>• Dato o ejemplo concreto (sin saturar la diapositiva)</a:t>
+            </a:r>
+          </a:p>
+        </p:txBody>
+      </p:sp>
+    </p:spTree>
+  </p:cSld>
+  <p:clrMapOvr>
+    <a:masterClrMapping/>
+  </p:clrMapOvr>
+</p:sld>
+</file>
+
+<file path=ppt/slides/slide5.xml><?xml version="1.0" encoding="utf-8"?>
+<p:sld xmlns:a="http://schemas.openxmlformats.org/drawingml/2006/main" xmlns:p="http://schemas.openxmlformats.org/presentationml/2006/main" xmlns:r="http://schemas.openxmlformats.org/officeDocument/2006/relationships">
+  <p:cSld>
+    <p:spTree>
+      <p:nvGrpSpPr>
+        <p:cNvPr id="1" name=""/>
+        <p:cNvGrpSpPr/>
+        <p:nvPr/>
+      </p:nvGrpSpPr>
+      <p:grpSpPr/>
+      <p:sp>
+        <p:nvSpPr>
+          <p:cNvPr id="2" name="Rectangle 1"/>
+          <p:cNvSpPr/>
+          <p:nvPr/>
+        </p:nvSpPr>
+        <p:spPr>
+          <a:xfrm>
+            <a:off x="0" y="0"/>
+            <a:ext cx="12191695" cy="6858000"/>
+          </a:xfrm>
+          <a:prstGeom prst="rect">
+            <a:avLst/>
+          </a:prstGeom>
+          <a:solidFill>
+            <a:srgbClr val="FFFFFF"/>
+          </a:solidFill>
+          <a:ln>
+            <a:noFill/>
+          </a:ln>
+        </p:spPr>
+        <p:style>
+          <a:lnRef idx="1">
+            <a:schemeClr val="accent1"/>
+          </a:lnRef>
+          <a:fillRef idx="3">
+            <a:schemeClr val="accent1"/>
+          </a:fillRef>
+          <a:effectRef idx="2">
+            <a:schemeClr val="accent1"/>
+          </a:effectRef>
+          <a:fontRef idx="minor">
+            <a:schemeClr val="lt1"/>
+          </a:fontRef>
+        </p:style>
+        <p:txBody>
+          <a:bodyPr rtlCol="0" anchor="ctr"/>
+          <a:lstStyle/>
+          <a:p>
+            <a:pPr algn="ctr"/>
+          </a:p>
+        </p:txBody>
+      </p:sp>
+      <p:sp>
+        <p:nvSpPr>
+          <p:cNvPr id="3" name="Rectangle 2"/>
+          <p:cNvSpPr/>
+          <p:nvPr/>
+        </p:nvSpPr>
+        <p:spPr>
+          <a:xfrm>
+            <a:off x="0" y="0"/>
+            <a:ext cx="12191695" cy="1051560"/>
+          </a:xfrm>
+          <a:prstGeom prst="rect">
+            <a:avLst/>
+          </a:prstGeom>
+          <a:solidFill>
+            <a:srgbClr val="042F23"/>
+          </a:solidFill>
+          <a:ln>
+            <a:noFill/>
+          </a:ln>
+        </p:spPr>
+        <p:style>
+          <a:lnRef idx="1">
+            <a:schemeClr val="accent1"/>
+          </a:lnRef>
+          <a:fillRef idx="3">
+            <a:schemeClr val="accent1"/>
+          </a:fillRef>
+          <a:effectRef idx="2">
+            <a:schemeClr val="accent1"/>
+          </a:effectRef>
+          <a:fontRef idx="minor">
+            <a:schemeClr val="lt1"/>
+          </a:fontRef>
+        </p:style>
+        <p:txBody>
+          <a:bodyPr rtlCol="0" anchor="ctr"/>
+          <a:lstStyle/>
+          <a:p>
+            <a:pPr algn="ctr"/>
+          </a:p>
+        </p:txBody>
+      </p:sp>
+      <p:sp>
+        <p:nvSpPr>
+          <p:cNvPr id="4" name="Rectangle 3"/>
+          <p:cNvSpPr/>
+          <p:nvPr/>
+        </p:nvSpPr>
+        <p:spPr>
+          <a:xfrm>
+            <a:off x="0" y="1051560"/>
+            <a:ext cx="12191695" cy="45720"/>
+          </a:xfrm>
+          <a:prstGeom prst="rect">
+            <a:avLst/>
+          </a:prstGeom>
+          <a:solidFill>
+            <a:srgbClr val="C9A227"/>
+          </a:solidFill>
+          <a:ln>
+            <a:noFill/>
+          </a:ln>
+        </p:spPr>
+        <p:style>
+          <a:lnRef idx="1">
+            <a:schemeClr val="accent1"/>
+          </a:lnRef>
+          <a:fillRef idx="3">
+            <a:schemeClr val="accent1"/>
+          </a:fillRef>
+          <a:effectRef idx="2">
+            <a:schemeClr val="accent1"/>
+          </a:effectRef>
+          <a:fontRef idx="minor">
+            <a:schemeClr val="lt1"/>
+          </a:fontRef>
+        </p:style>
+        <p:txBody>
+          <a:bodyPr rtlCol="0" anchor="ctr"/>
+          <a:lstStyle/>
+          <a:p>
+            <a:pPr algn="ctr"/>
+          </a:p>
+        </p:txBody>
+      </p:sp>
+      <p:pic>
+        <p:nvPicPr>
+          <p:cNvPr id="5" name="Picture 4" descr="logo-observatorio-ia-circle.png"/>
+          <p:cNvPicPr>
+            <a:picLocks noChangeAspect="1"/>
+          </p:cNvPicPr>
+          <p:nvPr/>
+        </p:nvPicPr>
+        <p:blipFill>
+          <a:blip r:embed="rId2"/>
+          <a:stretch>
+            <a:fillRect/>
+          </a:stretch>
+        </p:blipFill>
+        <p:spPr>
+          <a:xfrm>
+            <a:off x="274320" y="109728"/>
+            <a:ext cx="822960" cy="822960"/>
+          </a:xfrm>
+          <a:prstGeom prst="rect">
+            <a:avLst/>
+          </a:prstGeom>
+        </p:spPr>
+      </p:pic>
+      <p:sp>
+        <p:nvSpPr>
+          <p:cNvPr id="6" name="TextBox 5"/>
+          <p:cNvSpPr txBox="1"/>
+          <p:nvPr/>
+        </p:nvSpPr>
+        <p:spPr>
+          <a:xfrm>
+            <a:off x="1280160" y="164592"/>
+            <a:ext cx="9601200" cy="822960"/>
+          </a:xfrm>
+          <a:prstGeom prst="rect">
+            <a:avLst/>
+          </a:prstGeom>
+          <a:noFill/>
+        </p:spPr>
+        <p:txBody>
+          <a:bodyPr wrap="square">
+            <a:spAutoFit/>
+          </a:bodyPr>
+          <a:lstStyle/>
+          <a:p>
+            <a:pPr algn="l">
+              <a:spcAft>
+                <a:spcPts val="800"/>
+              </a:spcAft>
+            </a:pPr>
+            <a:r>
+              <a:rPr sz="1100" b="0">
+                <a:solidFill>
+                  <a:srgbClr val="FFFFFF"/>
+                </a:solidFill>
+                <a:latin typeface="Calibri"/>
+              </a:rPr>
+              <a:t>UNIVERSIDAD CATÓLICA DE CUYO · Observatorio de IA</a:t>
+            </a:r>
+          </a:p>
+          <a:p>
+            <a:pPr algn="l">
+              <a:spcAft>
+                <a:spcPts val="800"/>
+              </a:spcAft>
+            </a:pPr>
+            <a:r>
+              <a:rPr sz="1800" b="1">
+                <a:solidFill>
+                  <a:srgbClr val="FFFFFF"/>
+                </a:solidFill>
+                <a:latin typeface="Calibri"/>
+              </a:rPr>
+              <a:t>1° Jornadas internas de Inteligencia Artificial 2026</a:t>
+            </a:r>
+          </a:p>
+          <a:p>
+            <a:pPr algn="l">
+              <a:spcAft>
+                <a:spcPts val="800"/>
+              </a:spcAft>
+            </a:pPr>
+            <a:r>
+              <a:rPr sz="1200" b="0">
+                <a:solidFill>
+                  <a:srgbClr val="FFFFFF"/>
+                </a:solidFill>
+                <a:latin typeface="Calibri"/>
+              </a:rPr>
+              <a:t>Encuentro virtual · 6 de octubre de 2026 · 15:00 h</a:t>
+            </a:r>
+          </a:p>
+        </p:txBody>
+      </p:sp>
+      <p:sp>
+        <p:nvSpPr>
+          <p:cNvPr id="7" name="Rectangle 6"/>
+          <p:cNvSpPr/>
+          <p:nvPr/>
+        </p:nvSpPr>
+        <p:spPr>
+          <a:xfrm>
+            <a:off x="0" y="6492240"/>
+            <a:ext cx="12191695" cy="365760"/>
+          </a:xfrm>
+          <a:prstGeom prst="rect">
+            <a:avLst/>
+          </a:prstGeom>
+          <a:solidFill>
+            <a:srgbClr val="064A38"/>
+          </a:solidFill>
+          <a:ln>
+            <a:noFill/>
+          </a:ln>
+        </p:spPr>
+        <p:style>
+          <a:lnRef idx="1">
+            <a:schemeClr val="accent1"/>
+          </a:lnRef>
+          <a:fillRef idx="3">
+            <a:schemeClr val="accent1"/>
+          </a:fillRef>
+          <a:effectRef idx="2">
+            <a:schemeClr val="accent1"/>
+          </a:effectRef>
+          <a:fontRef idx="minor">
+            <a:schemeClr val="lt1"/>
+          </a:fontRef>
+        </p:style>
+        <p:txBody>
+          <a:bodyPr rtlCol="0" anchor="ctr"/>
+          <a:lstStyle/>
+          <a:p>
+            <a:pPr algn="ctr"/>
+          </a:p>
+        </p:txBody>
+      </p:sp>
+      <p:sp>
+        <p:nvSpPr>
+          <p:cNvPr id="8" name="TextBox 7"/>
+          <p:cNvSpPr txBox="1"/>
+          <p:nvPr/>
+        </p:nvSpPr>
+        <p:spPr>
+          <a:xfrm>
+            <a:off x="365760" y="6528816"/>
+            <a:ext cx="10515600" cy="292608"/>
+          </a:xfrm>
+          <a:prstGeom prst="rect">
+            <a:avLst/>
+          </a:prstGeom>
+          <a:noFill/>
+        </p:spPr>
+        <p:txBody>
+          <a:bodyPr wrap="square">
+            <a:spAutoFit/>
+          </a:bodyPr>
+          <a:lstStyle/>
+          <a:p>
+            <a:pPr algn="ctr">
+              <a:spcAft>
+                <a:spcPts val="800"/>
+              </a:spcAft>
+            </a:pPr>
+            <a:r>
+              <a:rPr sz="1100" b="0">
+                <a:solidFill>
+                  <a:srgbClr val="FFFFFF"/>
+                </a:solidFill>
+                <a:latin typeface="Calibri"/>
+              </a:rPr>
+              <a:t>Observatorio de IA · UCCuyo  ·  Diapositiva 5/6  ·  https://claudiomlarrea.github.io/observatorio-ia/#jornadas-ia</a:t>
+            </a:r>
+          </a:p>
+        </p:txBody>
+      </p:sp>
+      <p:sp>
+        <p:nvSpPr>
+          <p:cNvPr id="9" name="TextBox 8"/>
+          <p:cNvSpPr txBox="1"/>
+          <p:nvPr/>
+        </p:nvSpPr>
+        <p:spPr>
+          <a:xfrm>
+            <a:off x="548640" y="1280160"/>
+            <a:ext cx="10972800" cy="502920"/>
+          </a:xfrm>
+          <a:prstGeom prst="rect">
+            <a:avLst/>
+          </a:prstGeom>
+          <a:noFill/>
+        </p:spPr>
+        <p:txBody>
+          <a:bodyPr wrap="square">
+            <a:spAutoFit/>
+          </a:bodyPr>
+          <a:lstStyle/>
+          <a:p>
+            <a:pPr algn="l">
+              <a:spcAft>
+                <a:spcPts val="800"/>
+              </a:spcAft>
+            </a:pPr>
+            <a:r>
+              <a:rPr sz="2600" b="1">
+                <a:solidFill>
+                  <a:srgbClr val="042F23"/>
+                </a:solidFill>
+                <a:latin typeface="Calibri"/>
+              </a:rPr>
+              <a:t>5. Conclusiones</a:t>
+            </a:r>
+          </a:p>
+        </p:txBody>
+      </p:sp>
+      <p:sp>
+        <p:nvSpPr>
+          <p:cNvPr id="10" name="Rounded Rectangle 9"/>
+          <p:cNvSpPr/>
+          <p:nvPr/>
+        </p:nvSpPr>
+        <p:spPr>
+          <a:xfrm>
+            <a:off x="548640" y="1920240"/>
+            <a:ext cx="11064240" cy="4206240"/>
+          </a:xfrm>
+          <a:prstGeom prst="roundRect">
+            <a:avLst/>
+          </a:prstGeom>
+          <a:solidFill>
+            <a:srgbClr val="F4F8F6"/>
+          </a:solidFill>
+          <a:ln w="15875">
+            <a:solidFill>
+              <a:srgbClr val="064A38"/>
+            </a:solidFill>
+          </a:ln>
+        </p:spPr>
+        <p:style>
+          <a:lnRef idx="1">
+            <a:schemeClr val="accent1"/>
+          </a:lnRef>
+          <a:fillRef idx="3">
+            <a:schemeClr val="accent1"/>
+          </a:fillRef>
+          <a:effectRef idx="2">
+            <a:schemeClr val="accent1"/>
+          </a:effectRef>
+          <a:fontRef idx="minor">
+            <a:schemeClr val="lt1"/>
+          </a:fontRef>
+        </p:style>
+        <p:txBody>
+          <a:bodyPr rtlCol="0" anchor="ctr" wrap="square"/>
+          <a:lstStyle/>
+          <a:p>
+            <a:pPr algn="l">
+              <a:spcAft>
+                <a:spcPts val="800"/>
+              </a:spcAft>
+            </a:pPr>
+            <a:r>
+              <a:rPr sz="1800" b="1">
+                <a:solidFill>
+                  <a:srgbClr val="042F23"/>
+                </a:solidFill>
+                <a:latin typeface="Calibri"/>
+              </a:rPr>
+              <a:t>Mensajes clave para llevarse</a:t>
+            </a:r>
+          </a:p>
+          <a:p>
+            <a:pPr algn="l">
+              <a:spcAft>
+                <a:spcPts val="800"/>
+              </a:spcAft>
+            </a:pPr>
+            <a:r>
+              <a:rPr sz="1600" b="0">
+                <a:solidFill>
+                  <a:srgbClr val="1F1418"/>
+                </a:solidFill>
+                <a:latin typeface="Calibri"/>
+              </a:rPr>
+              <a:t>• Conclusión 1</a:t>
+            </a:r>
+          </a:p>
+          <a:p>
+            <a:pPr algn="l">
+              <a:spcAft>
+                <a:spcPts val="800"/>
+              </a:spcAft>
+            </a:pPr>
+            <a:r>
+              <a:rPr sz="1600" b="0">
+                <a:solidFill>
+                  <a:srgbClr val="1F1418"/>
+                </a:solidFill>
+                <a:latin typeface="Calibri"/>
+              </a:rPr>
+              <a:t>• Conclusión 2</a:t>
+            </a:r>
+          </a:p>
+          <a:p>
+            <a:pPr algn="l">
+              <a:spcAft>
+                <a:spcPts val="800"/>
+              </a:spcAft>
+            </a:pPr>
+            <a:r>
+              <a:rPr sz="1600" b="0">
+                <a:solidFill>
+                  <a:srgbClr val="1F1418"/>
+                </a:solidFill>
+                <a:latin typeface="Calibri"/>
+              </a:rPr>
+              <a:t>• Implicancias o próximos pasos</a:t>
+            </a:r>
+          </a:p>
+        </p:txBody>
+      </p:sp>
+    </p:spTree>
+  </p:cSld>
+  <p:clrMapOvr>
+    <a:masterClrMapping/>
+  </p:clrMapOvr>
+</p:sld>
+</file>
+
+<file path=ppt/slides/slide6.xml><?xml version="1.0" encoding="utf-8"?>
+<p:sld xmlns:a="http://schemas.openxmlformats.org/drawingml/2006/main" xmlns:p="http://schemas.openxmlformats.org/presentationml/2006/main" xmlns:r="http://schemas.openxmlformats.org/officeDocument/2006/relationships">
+  <p:cSld>
+    <p:spTree>
+      <p:nvGrpSpPr>
+        <p:cNvPr id="1" name=""/>
+        <p:cNvGrpSpPr/>
+        <p:nvPr/>
+      </p:nvGrpSpPr>
+      <p:grpSpPr/>
+      <p:sp>
+        <p:nvSpPr>
+          <p:cNvPr id="2" name="Rectangle 1"/>
+          <p:cNvSpPr/>
+          <p:nvPr/>
+        </p:nvSpPr>
+        <p:spPr>
+          <a:xfrm>
+            <a:off x="0" y="0"/>
+            <a:ext cx="12191695" cy="6858000"/>
+          </a:xfrm>
+          <a:prstGeom prst="rect">
+            <a:avLst/>
+          </a:prstGeom>
+          <a:solidFill>
+            <a:srgbClr val="FFFFFF"/>
+          </a:solidFill>
+          <a:ln>
+            <a:noFill/>
+          </a:ln>
+        </p:spPr>
+        <p:style>
+          <a:lnRef idx="1">
+            <a:schemeClr val="accent1"/>
+          </a:lnRef>
+          <a:fillRef idx="3">
+            <a:schemeClr val="accent1"/>
+          </a:fillRef>
+          <a:effectRef idx="2">
+            <a:schemeClr val="accent1"/>
+          </a:effectRef>
+          <a:fontRef idx="minor">
+            <a:schemeClr val="lt1"/>
+          </a:fontRef>
+        </p:style>
+        <p:txBody>
+          <a:bodyPr rtlCol="0" anchor="ctr"/>
+          <a:lstStyle/>
+          <a:p>
+            <a:pPr algn="ctr"/>
+          </a:p>
+        </p:txBody>
+      </p:sp>
+      <p:sp>
+        <p:nvSpPr>
+          <p:cNvPr id="3" name="Rectangle 2"/>
+          <p:cNvSpPr/>
+          <p:nvPr/>
+        </p:nvSpPr>
+        <p:spPr>
+          <a:xfrm>
+            <a:off x="0" y="0"/>
+            <a:ext cx="12191695" cy="1051560"/>
+          </a:xfrm>
+          <a:prstGeom prst="rect">
+            <a:avLst/>
+          </a:prstGeom>
+          <a:solidFill>
+            <a:srgbClr val="042F23"/>
+          </a:solidFill>
+          <a:ln>
+            <a:noFill/>
+          </a:ln>
+        </p:spPr>
+        <p:style>
+          <a:lnRef idx="1">
+            <a:schemeClr val="accent1"/>
+          </a:lnRef>
+          <a:fillRef idx="3">
+            <a:schemeClr val="accent1"/>
+          </a:fillRef>
+          <a:effectRef idx="2">
+            <a:schemeClr val="accent1"/>
+          </a:effectRef>
+          <a:fontRef idx="minor">
+            <a:schemeClr val="lt1"/>
+          </a:fontRef>
+        </p:style>
+        <p:txBody>
+          <a:bodyPr rtlCol="0" anchor="ctr"/>
+          <a:lstStyle/>
+          <a:p>
+            <a:pPr algn="ctr"/>
+          </a:p>
+        </p:txBody>
+      </p:sp>
+      <p:sp>
+        <p:nvSpPr>
+          <p:cNvPr id="4" name="Rectangle 3"/>
+          <p:cNvSpPr/>
+          <p:nvPr/>
+        </p:nvSpPr>
+        <p:spPr>
+          <a:xfrm>
+            <a:off x="0" y="1051560"/>
+            <a:ext cx="12191695" cy="45720"/>
+          </a:xfrm>
+          <a:prstGeom prst="rect">
+            <a:avLst/>
+          </a:prstGeom>
+          <a:solidFill>
+            <a:srgbClr val="C9A227"/>
+          </a:solidFill>
+          <a:ln>
+            <a:noFill/>
+          </a:ln>
+        </p:spPr>
+        <p:style>
+          <a:lnRef idx="1">
+            <a:schemeClr val="accent1"/>
+          </a:lnRef>
+          <a:fillRef idx="3">
+            <a:schemeClr val="accent1"/>
+          </a:fillRef>
+          <a:effectRef idx="2">
+            <a:schemeClr val="accent1"/>
+          </a:effectRef>
+          <a:fontRef idx="minor">
+            <a:schemeClr val="lt1"/>
+          </a:fontRef>
+        </p:style>
+        <p:txBody>
+          <a:bodyPr rtlCol="0" anchor="ctr"/>
+          <a:lstStyle/>
+          <a:p>
+            <a:pPr algn="ctr"/>
+          </a:p>
+        </p:txBody>
+      </p:sp>
+      <p:pic>
+        <p:nvPicPr>
+          <p:cNvPr id="5" name="Picture 4" descr="logo-observatorio-ia-circle.png"/>
+          <p:cNvPicPr>
+            <a:picLocks noChangeAspect="1"/>
+          </p:cNvPicPr>
+          <p:nvPr/>
+        </p:nvPicPr>
+        <p:blipFill>
+          <a:blip r:embed="rId2"/>
+          <a:stretch>
+            <a:fillRect/>
+          </a:stretch>
+        </p:blipFill>
+        <p:spPr>
+          <a:xfrm>
+            <a:off x="274320" y="109728"/>
+            <a:ext cx="822960" cy="822960"/>
+          </a:xfrm>
+          <a:prstGeom prst="rect">
+            <a:avLst/>
+          </a:prstGeom>
+        </p:spPr>
+      </p:pic>
+      <p:sp>
+        <p:nvSpPr>
+          <p:cNvPr id="6" name="TextBox 5"/>
+          <p:cNvSpPr txBox="1"/>
+          <p:nvPr/>
+        </p:nvSpPr>
+        <p:spPr>
+          <a:xfrm>
+            <a:off x="1280160" y="164592"/>
+            <a:ext cx="9601200" cy="822960"/>
+          </a:xfrm>
+          <a:prstGeom prst="rect">
+            <a:avLst/>
+          </a:prstGeom>
+          <a:noFill/>
+        </p:spPr>
+        <p:txBody>
+          <a:bodyPr wrap="square">
+            <a:spAutoFit/>
+          </a:bodyPr>
+          <a:lstStyle/>
+          <a:p>
+            <a:pPr algn="l">
+              <a:spcAft>
+                <a:spcPts val="800"/>
+              </a:spcAft>
+            </a:pPr>
+            <a:r>
+              <a:rPr sz="1100" b="0">
+                <a:solidFill>
+                  <a:srgbClr val="FFFFFF"/>
+                </a:solidFill>
+                <a:latin typeface="Calibri"/>
+              </a:rPr>
+              <a:t>UNIVERSIDAD CATÓLICA DE CUYO · Observatorio de IA</a:t>
+            </a:r>
+          </a:p>
+          <a:p>
+            <a:pPr algn="l">
+              <a:spcAft>
+                <a:spcPts val="800"/>
+              </a:spcAft>
+            </a:pPr>
+            <a:r>
+              <a:rPr sz="1800" b="1">
+                <a:solidFill>
+                  <a:srgbClr val="FFFFFF"/>
+                </a:solidFill>
+                <a:latin typeface="Calibri"/>
+              </a:rPr>
+              <a:t>1° Jornadas internas de Inteligencia Artificial 2026</a:t>
+            </a:r>
+          </a:p>
+          <a:p>
+            <a:pPr algn="l">
+              <a:spcAft>
+                <a:spcPts val="800"/>
+              </a:spcAft>
+            </a:pPr>
+            <a:r>
+              <a:rPr sz="1200" b="0">
+                <a:solidFill>
+                  <a:srgbClr val="FFFFFF"/>
+                </a:solidFill>
+                <a:latin typeface="Calibri"/>
+              </a:rPr>
+              <a:t>Encuentro virtual · 6 de octubre de 2026 · 15:00 h</a:t>
+            </a:r>
+          </a:p>
+        </p:txBody>
+      </p:sp>
+      <p:sp>
+        <p:nvSpPr>
+          <p:cNvPr id="7" name="Rectangle 6"/>
+          <p:cNvSpPr/>
+          <p:nvPr/>
+        </p:nvSpPr>
+        <p:spPr>
+          <a:xfrm>
+            <a:off x="0" y="6492240"/>
+            <a:ext cx="12191695" cy="365760"/>
+          </a:xfrm>
+          <a:prstGeom prst="rect">
+            <a:avLst/>
+          </a:prstGeom>
+          <a:solidFill>
+            <a:srgbClr val="064A38"/>
+          </a:solidFill>
+          <a:ln>
+            <a:noFill/>
+          </a:ln>
+        </p:spPr>
+        <p:style>
+          <a:lnRef idx="1">
+            <a:schemeClr val="accent1"/>
+          </a:lnRef>
+          <a:fillRef idx="3">
+            <a:schemeClr val="accent1"/>
+          </a:fillRef>
+          <a:effectRef idx="2">
+            <a:schemeClr val="accent1"/>
+          </a:effectRef>
+          <a:fontRef idx="minor">
+            <a:schemeClr val="lt1"/>
+          </a:fontRef>
+        </p:style>
+        <p:txBody>
+          <a:bodyPr rtlCol="0" anchor="ctr"/>
+          <a:lstStyle/>
+          <a:p>
+            <a:pPr algn="ctr"/>
+          </a:p>
+        </p:txBody>
+      </p:sp>
+      <p:sp>
+        <p:nvSpPr>
+          <p:cNvPr id="8" name="TextBox 7"/>
+          <p:cNvSpPr txBox="1"/>
+          <p:nvPr/>
+        </p:nvSpPr>
+        <p:spPr>
+          <a:xfrm>
+            <a:off x="365760" y="6528816"/>
+            <a:ext cx="10515600" cy="292608"/>
+          </a:xfrm>
+          <a:prstGeom prst="rect">
+            <a:avLst/>
+          </a:prstGeom>
+          <a:noFill/>
+        </p:spPr>
+        <p:txBody>
+          <a:bodyPr wrap="square">
+            <a:spAutoFit/>
+          </a:bodyPr>
+          <a:lstStyle/>
+          <a:p>
+            <a:pPr algn="ctr">
+              <a:spcAft>
+                <a:spcPts val="800"/>
+              </a:spcAft>
+            </a:pPr>
+            <a:r>
+              <a:rPr sz="1100" b="0">
+                <a:solidFill>
+                  <a:srgbClr val="FFFFFF"/>
+                </a:solidFill>
+                <a:latin typeface="Calibri"/>
+              </a:rPr>
+              <a:t>Observatorio de IA · UCCuyo  ·  Diapositiva 6/6  ·  https://claudiomlarrea.github.io/observatorio-ia/#jornadas-ia</a:t>
+            </a:r>
+          </a:p>
+        </p:txBody>
+      </p:sp>
+      <p:sp>
+        <p:nvSpPr>
+          <p:cNvPr id="9" name="TextBox 8"/>
+          <p:cNvSpPr txBox="1"/>
+          <p:nvPr/>
+        </p:nvSpPr>
+        <p:spPr>
+          <a:xfrm>
+            <a:off x="548640" y="1280160"/>
+            <a:ext cx="10972800" cy="502920"/>
+          </a:xfrm>
+          <a:prstGeom prst="rect">
+            <a:avLst/>
+          </a:prstGeom>
+          <a:noFill/>
+        </p:spPr>
+        <p:txBody>
+          <a:bodyPr wrap="square">
+            <a:spAutoFit/>
+          </a:bodyPr>
+          <a:lstStyle/>
+          <a:p>
+            <a:pPr algn="l">
+              <a:spcAft>
+                <a:spcPts val="800"/>
+              </a:spcAft>
+            </a:pPr>
+            <a:r>
+              <a:rPr sz="2600" b="1">
+                <a:solidFill>
+                  <a:srgbClr val="042F23"/>
+                </a:solidFill>
+                <a:latin typeface="Calibri"/>
+              </a:rPr>
+              <a:t>6. Cierre</a:t>
+            </a:r>
+          </a:p>
+        </p:txBody>
+      </p:sp>
+      <p:sp>
+        <p:nvSpPr>
+          <p:cNvPr id="10" name="Rounded Rectangle 9"/>
+          <p:cNvSpPr/>
+          <p:nvPr/>
+        </p:nvSpPr>
+        <p:spPr>
+          <a:xfrm>
+            <a:off x="548640" y="1920240"/>
+            <a:ext cx="11064240" cy="4206240"/>
+          </a:xfrm>
+          <a:prstGeom prst="roundRect">
+            <a:avLst/>
+          </a:prstGeom>
+          <a:solidFill>
+            <a:srgbClr val="F4F8F6"/>
+          </a:solidFill>
+          <a:ln w="15875">
+            <a:solidFill>
+              <a:srgbClr val="064A38"/>
+            </a:solidFill>
+          </a:ln>
+        </p:spPr>
+        <p:style>
+          <a:lnRef idx="1">
+            <a:schemeClr val="accent1"/>
+          </a:lnRef>
+          <a:fillRef idx="3">
+            <a:schemeClr val="accent1"/>
+          </a:fillRef>
+          <a:effectRef idx="2">
+            <a:schemeClr val="accent1"/>
+          </a:effectRef>
+          <a:fontRef idx="minor">
+            <a:schemeClr val="lt1"/>
+          </a:fontRef>
+        </p:style>
+        <p:txBody>
+          <a:bodyPr rtlCol="0" anchor="ctr" wrap="square"/>
+          <a:lstStyle/>
+          <a:p>
+            <a:pPr algn="l">
+              <a:spcAft>
+                <a:spcPts val="800"/>
+              </a:spcAft>
+            </a:pPr>
+            <a:r>
+              <a:rPr sz="3200" b="1">
+                <a:solidFill>
+                  <a:srgbClr val="042F23"/>
+                </a:solidFill>
+                <a:latin typeface="Calibri"/>
+              </a:rPr>
+              <a:t>Gracias</a:t>
+            </a:r>
+          </a:p>
+          <a:p>
+            <a:pPr algn="l">
+              <a:spcAft>
+                <a:spcPts val="800"/>
+              </a:spcAft>
+            </a:pPr>
+            <a:r>
+              <a:rPr sz="1000" b="0">
+                <a:solidFill>
+                  <a:srgbClr val="5C4F54"/>
+                </a:solidFill>
+                <a:latin typeface="Calibri"/>
+              </a:rPr>
+              <a:t/>
+            </a:r>
+          </a:p>
+          <a:p>
+            <a:pPr algn="l">
+              <a:spcAft>
+                <a:spcPts val="800"/>
+              </a:spcAft>
+            </a:pPr>
+            <a:r>
+              <a:rPr sz="1800" b="0">
+                <a:solidFill>
+                  <a:srgbClr val="1F1418"/>
+                </a:solidFill>
+                <a:latin typeface="Calibri"/>
+              </a:rPr>
+              <a:t>Preguntas y comentarios</a:t>
+            </a:r>
+          </a:p>
+          <a:p>
+            <a:pPr algn="l">
+              <a:spcAft>
+                <a:spcPts val="800"/>
+              </a:spcAft>
+            </a:pPr>
+            <a:r>
+              <a:rPr sz="1600" b="0">
+                <a:solidFill>
+                  <a:srgbClr val="5C4F54"/>
+                </a:solidFill>
+                <a:latin typeface="Calibri"/>
+              </a:rPr>
+              <a:t>correo@uccuyo.edu.ar</a:t>
+            </a:r>
+          </a:p>
+          <a:p>
+            <a:pPr algn="l">
+              <a:spcAft>
+                <a:spcPts val="800"/>
+              </a:spcAft>
+            </a:pPr>
+            <a:r>
+              <a:rPr sz="1000" b="0">
+                <a:solidFill>
+                  <a:srgbClr val="5C4F54"/>
+                </a:solidFill>
+                <a:latin typeface="Calibri"/>
+              </a:rPr>
+              <a:t/>
+            </a:r>
+          </a:p>
+          <a:p>
+            <a:pPr algn="l">
+              <a:spcAft>
+                <a:spcPts val="800"/>
+              </a:spcAft>
+            </a:pPr>
+            <a:r>
+              <a:rPr sz="1400" b="0">
+                <a:solidFill>
+                  <a:srgbClr val="5C4F54"/>
+                </a:solidFill>
+                <a:latin typeface="Calibri"/>
+              </a:rPr>
+              <a:t>Exposición: hasta 10 minutos · Máximo 6 diapositivas · Carga hasta el 10 de septiembre de 2026</a:t>
             </a:r>
           </a:p>
         </p:txBody>

</xml_diff>